<commit_message>
Refine PACT-GP framing and study training defaults
Introduce the PACT-GP title, overall framework overview, selective emphasis, synchronized editable figures, and 200-individual/50-generation training defaults with regression coverage.

Co-authored-by: Copilot <223556219+Copilot@users.noreply.github.com>
</commit_message>
<xml_diff>
--- a/Research/TASE_GP_Agent_Skills/figures/gp_agent_skills/gp_agent_skills_figures.pptx
+++ b/Research/TASE_GP_Agent_Skills/figures/gp_agent_skills/gp_agent_skills_figures.pptx
@@ -507,7 +507,7 @@
           <a:lstStyle/>
           <a:p>
             <a:r>
-              <a:t>One shared GP policy, many local peer agents</a:t>
+              <a:t>PACT-GP: one shared policy, many local peer agents</a:t>
             </a:r>
           </a:p>
           <a:p>
@@ -667,7 +667,7 @@
           <a:lstStyle/>
           <a:p>
             <a:r>
-              <a:t>Offline GP search and leakage-free policy selection</a:t>
+              <a:t>PACT-GP: offline search and leakage-free policy selection</a:t>
             </a:r>
           </a:p>
           <a:p>
@@ -4018,7 +4018,7 @@
                 </a:solidFill>
                 <a:latin typeface="Arial"/>
               </a:rPr>
-              <a:t>One shared GP policy, many local peer agents</a:t>
+              <a:t>PACT-GP: one shared policy, many local peer agents</a:t>
             </a:r>
           </a:p>
         </p:txBody>
@@ -8376,7 +8376,7 @@
                 </a:solidFill>
                 <a:latin typeface="Arial"/>
               </a:rPr>
-              <a:t>Offline GP search and leakage-free policy selection</a:t>
+              <a:t>PACT-GP: offline search and leakage-free policy selection</a:t>
             </a:r>
           </a:p>
         </p:txBody>
@@ -10049,7 +10049,7 @@
                 </a:solidFill>
                 <a:latin typeface="Arial"/>
               </a:rPr>
-              <a:t>Central simulation: offline only.</a:t>
+              <a:t>Study budget: P &gt;= 200; G &gt;= 50.</a:t>
             </a:r>
           </a:p>
           <a:p>

</xml_diff>